<commit_message>
docs: record decisions, assume Pro plans, re-export Session 5 slides
Co-Authored-By: Claude Sonnet 5.5 <noreply@anthropic.com>
Claude-Session: https://claude.ai/code/session_01YFvdQzy9s2H489HHdL2tyH
</commit_message>
<xml_diff>
--- a/training/session_5/slides/session-5-kickoff.pptx
+++ b/training/session_5/slides/session-5-kickoff.pptx
@@ -658,7 +658,7 @@
           <a:lstStyle/>
           <a:p>
             <a:r>
-              <a:t>Leave this slide up as a reference during setup; do not present it. The three rows cover the problems we expect most. Before the session, test the setup yourself with a free account to find out exactly which step it blocks, then replace the third row with the real answer. If someone is stuck for more than 10 minutes, pair them with a classmate who has finished instead of solving it live in front of everyone. Note down every problem that comes up: it becomes the first skill material later.</a:t>
+              <a:t>Leave this slide up as a reference during setup; do not present it. The three rows cover the problems we expect most. Everyone in the course has a Claude Pro plan, so plan limits should not block a step. If someone is stuck for more than 10 minutes, pair them with a classmate who has finished instead of solving it live in front of everyone. Note down every problem that comes up: it becomes the first skill material later.</a:t>
             </a:r>
           </a:p>
         </p:txBody>
@@ -728,7 +728,7 @@
           <a:lstStyle/>
           <a:p>
             <a:r>
-              <a:t>Each participant takes one of the starter tickets and follows the eight steps. The first ticket is easy on purpose (for example, fix the site title in Café Cumbre) because the goal is the process, not the code. Walk around and watch for: the branch name, the ticket number in commit and PR, and whether the CI actually ran. Reviews: each person reviews the PR of the person to their left, so every PR gets one review. If CI is not green because of a setup problem, fix it with the group and write down the problem in a ticket. Aim to have the first PRs merged in the first 40 minutes, leaving the last 20 for reviews and Jira comments. The tickets used here are the starter tickets prepared before the session.</a:t>
+              <a:t>Each participant takes one of the starter tickets and follows the eight steps. The first ticket is easy on purpose (for example, fix the typo in the menu of the Summit Cafe API) because the goal is the process, not the code. Walk around and watch for: the branch name, the ticket number in commit and PR, and whether the CI actually ran. Reviews: each person reviews the PR of the person to their left, so every PR gets one review. If CI is not green because of a setup problem, fix it with the group and write down the problem in a ticket. Aim to have the first PRs merged in the first 40 minutes, leaving the last 20 for reviews and Jira comments. The tickets used here are the starter tickets prepared before the session (see training/docs/starter-tickets.md in the repository).</a:t>
             </a:r>
           </a:p>
         </p:txBody>
@@ -1288,7 +1288,7 @@
           <a:lstStyle/>
           <a:p>
             <a:r>
-              <a:t>This is the one slide where I explain how the course works. Key messages: (1) We have 12 sessions left, and most of the time is yours. (2) There are no exams or quizzes. What you do in GitHub and Jira is how we see your progress. (3) We build one main project together, Café Cumbre en línea, a small Flask API with an nginx site. Each session adds a capability to it. (4) The CertiProf exam is optional and separate. Each session will point out the key concepts for the exam, and in the last session you can practice with the official sample exam. Tell them: sessions 6 and 12 will be led by Patricia, who is a quality engineer. Keep this slide under 3 minutes.</a:t>
+              <a:t>This is the one slide where I explain how the course works. Key messages: (1) We have 12 sessions left, and most of the time is yours. (2) There are no exams or quizzes. What you do in GitHub and Jira is how we see your progress. (3) We build one main project together, the Summit Cafe API, a small Flask REST API that we can deploy to Render. Each session adds a capability to it. (4) The CertiProf exam is optional and separate. Each session will point out the key concepts for the exam, and in the last session you can practice with the official sample exam. Tell them: sessions 6 and 12 will be led by Patricia, who is a quality engineer. Keep this slide under 3 minutes.</a:t>
             </a:r>
           </a:p>
         </p:txBody>
@@ -1498,7 +1498,7 @@
           <a:lstStyle/>
           <a:p>
             <a:r>
-              <a:t>Our branching strategy has two permanent branches and short work branches. Main holds stable code that is ready to release. Develop is where all finished work is put together. Every work branch starts from develop and comes back to develop through a pull request, never directly. Branch names start with the type of work, feature or bugfix, then a slash, then the Jira ticket key. When develop is ready, it is released to main. Both main and develop are protected (nobody can push to them directly): only pull requests with passing tests and a review. Instructor note: this requires creating the develop branch and protecting both branches before the session, and setting develop as the branch that pull requests target by default. Replace SCRUM-12 with a real ticket number once the starter tickets exist. Allow about 5 minutes.</a:t>
+              <a:t>Our branching strategy has two permanent branches and short work branches. Main holds stable code that is ready to release. Develop is where all finished work is put together. Every work branch starts from develop and comes back to develop through a pull request, never directly. Branch names start with the type of work, feature or bugfix, then a slash, then the Jira ticket key. When develop is ready, it is released to main. Both main and develop are protected (nobody can push to them directly): only pull requests with passing tests and a review. Instructor note: this requires creating the develop branch and protecting both branches before the session, and setting develop as the branch that pull requests target by default. The examples use real starter tickets: SCRUM-9 (a feature) and SCRUM-5 (a bug fix). Allow about 5 minutes.</a:t>
             </a:r>
           </a:p>
         </p:txBody>
@@ -1638,7 +1638,7 @@
           <a:lstStyle/>
           <a:p>
             <a:r>
-              <a:t>Participants do this themselves. Keep this slide on screen while they work and walk around, or watch the chat. They should use Claude to guide them through each step: for example, "I just got an email invitation to a GitHub repository, what do I do?" Show on screen where to find the connections for GitHub and Jira in Claude's settings (the menu names change, so check them live before the session). Pair people: someone who already finished helps their neighbour. Free accounts: if a connection is blocked by plan limits, note who it is and keep going with a classmate. Expected time: 50 minutes, including problems. Anyone who finishes early moves to the next slide and verifies the connection.</a:t>
+              <a:t>Participants do this themselves. Keep this slide on screen while they work and walk around, or watch the chat. They should use Claude to guide them through each step: for example, "I just got an email invitation to a GitHub repository, what do I do?" Show on screen where to find the connections for GitHub and Jira in Claude's settings (the menu names change, so check them live before the session). Pair people: someone who already finished helps their neighbour. Everyone has a Claude Pro plan, so if a connection is blocked, check the account first. Expected time: 50 minutes, including problems. Anyone who finishes early moves to the next slide and verifies the connection.</a:t>
             </a:r>
           </a:p>
         </p:txBody>

</xml_diff>